<commit_message>
Refine Ramp It Up week resources
Co-authored-by: Cursor <cursoragent@cursor.com>
</commit_message>
<xml_diff>
--- a/production/slides/03-ch3-energy-speed-slides.pptx
+++ b/production/slides/03-ch3-energy-speed-slides.pptx
@@ -3223,7 +3223,7 @@
                 </a:solidFill>
                 <a:latin typeface="Arial"/>
               </a:rPr>
-              <a:t>Chapter 3  ·  Grade 4  ·  Week 3</a:t>
+              <a:t>Chapter 3  ·  Grade 4  ·  Week 2</a:t>
             </a:r>
           </a:p>
         </p:txBody>
@@ -3561,7 +3561,7 @@
                 </a:solidFill>
                 <a:latin typeface="Arial"/>
               </a:rPr>
-              <a:t>Notebook — speed</a:t>
+              <a:t>Notes — speed</a:t>
             </a:r>
           </a:p>
         </p:txBody>
@@ -9402,7 +9402,7 @@
                 </a:solidFill>
                 <a:latin typeface="Arial"/>
               </a:rPr>
-              <a:t>NOTEBOOK</a:t>
+              <a:t>NOTES</a:t>
             </a:r>
           </a:p>
         </p:txBody>

</xml_diff>

<commit_message>
Embed approved media into presentations (Phase 13L)
- Trimmed cuts (git-excluded sources) embedded as native mp4 media parts:
  - speed-and-energy-ramp-it-up-classroom-cut.mp4 -> 03-ch3 S17 (2:29)
  - journey-of-energy-unit1-recap-classroom-cut.mp4 -> 07-ch7 S13 (2:49)
- New tools/embed_video.py: portable OOXML media embed (poster + videoFile + p14:media)

Co-authored-by: Cursor <cursoragent@cursor.com>
</commit_message>
<xml_diff>
--- a/production/slides/03-ch3-energy-speed-slides.pptx
+++ b/production/slides/03-ch3-energy-speed-slides.pptx
@@ -21,6 +21,7 @@
     <p:sldId id="269" r:id="rId20"/>
     <p:sldId id="270" r:id="rId21"/>
     <p:sldId id="271" r:id="rId22"/>
+    <p:sldId id="284" r:id="rId35"/>
     <p:sldId id="272" r:id="rId23"/>
     <p:sldId id="273" r:id="rId24"/>
     <p:sldId id="274" r:id="rId25"/>
@@ -9020,6 +9021,296 @@
                 <a:latin typeface="Arial"/>
               </a:rPr>
               <a:t>28</a:t>
+            </a:r>
+          </a:p>
+        </p:txBody>
+      </p:sp>
+    </p:spTree>
+  </p:cSld>
+  <p:clrMapOvr>
+    <a:masterClrMapping/>
+  </p:clrMapOvr>
+</p:sld>
+</file>
+
+<file path=ppt/slides/slide29.xml><?xml version="1.0" encoding="utf-8"?>
+<p:sld xmlns:a="http://schemas.openxmlformats.org/drawingml/2006/main" xmlns:p="http://schemas.openxmlformats.org/presentationml/2006/main" xmlns:r="http://schemas.openxmlformats.org/officeDocument/2006/relationships">
+  <p:cSld>
+    <p:spTree>
+      <p:nvGrpSpPr>
+        <p:cNvPr id="1" name=""/>
+        <p:cNvGrpSpPr/>
+        <p:nvPr/>
+      </p:nvGrpSpPr>
+      <p:grpSpPr/>
+      <p:sp>
+        <p:nvSpPr>
+          <p:cNvPr id="2" name="Title Bar"/>
+          <p:cNvSpPr/>
+          <p:nvPr/>
+        </p:nvSpPr>
+        <p:spPr>
+          <a:xfrm>
+            <a:off x="0" y="0"/>
+            <a:ext cx="12191695" cy="1417320"/>
+          </a:xfrm>
+          <a:prstGeom prst="roundRect">
+            <a:avLst/>
+          </a:prstGeom>
+          <a:solidFill>
+            <a:srgbClr val="1F3A5F"/>
+          </a:solidFill>
+          <a:ln>
+            <a:noFill/>
+          </a:ln>
+        </p:spPr>
+        <p:style>
+          <a:lnRef idx="1">
+            <a:schemeClr val="accent1"/>
+          </a:lnRef>
+          <a:fillRef idx="3">
+            <a:schemeClr val="accent1"/>
+          </a:fillRef>
+          <a:effectRef idx="2">
+            <a:schemeClr val="accent1"/>
+          </a:effectRef>
+          <a:fontRef idx="minor">
+            <a:schemeClr val="lt1"/>
+          </a:fontRef>
+        </p:style>
+        <p:txBody>
+          <a:bodyPr rtlCol="0" anchor="ctr" wrap="square"/>
+          <a:lstStyle/>
+          <a:p>
+            <a:pPr algn="ctr"/>
+          </a:p>
+        </p:txBody>
+      </p:sp>
+      <p:sp>
+        <p:nvSpPr>
+          <p:cNvPr id="3" name="Title"/>
+          <p:cNvSpPr txBox="1"/>
+          <p:nvPr/>
+        </p:nvSpPr>
+        <p:spPr>
+          <a:xfrm>
+            <a:off x="457200" y="109728"/>
+            <a:ext cx="9855190" cy="868680"/>
+          </a:xfrm>
+          <a:prstGeom prst="rect">
+            <a:avLst/>
+          </a:prstGeom>
+          <a:noFill/>
+        </p:spPr>
+        <p:txBody>
+          <a:bodyPr wrap="square" anchor="ctr">
+            <a:spAutoFit/>
+          </a:bodyPr>
+          <a:lstStyle/>
+          <a:p>
+            <a:pPr algn="l"/>
+            <a:r>
+              <a:rPr sz="3200" b="1">
+                <a:solidFill>
+                  <a:srgbClr val="FFFFFF"/>
+                </a:solidFill>
+                <a:latin typeface="Arial"/>
+              </a:rPr>
+              <a:t>WATCH — Ramp It Up in Action</a:t>
+            </a:r>
+          </a:p>
+        </p:txBody>
+      </p:sp>
+      <p:sp>
+        <p:nvSpPr>
+          <p:cNvPr id="4" name="Subtitle"/>
+          <p:cNvSpPr txBox="1"/>
+          <p:nvPr/>
+        </p:nvSpPr>
+        <p:spPr>
+          <a:xfrm>
+            <a:off x="457200" y="1024128"/>
+            <a:ext cx="9855190" cy="329184"/>
+          </a:xfrm>
+          <a:prstGeom prst="rect">
+            <a:avLst/>
+          </a:prstGeom>
+          <a:noFill/>
+        </p:spPr>
+        <p:txBody>
+          <a:bodyPr wrap="square" anchor="ctr">
+            <a:spAutoFit/>
+          </a:bodyPr>
+          <a:lstStyle/>
+          <a:p>
+            <a:pPr algn="l"/>
+            <a:r>
+              <a:rPr sz="1500" b="0">
+                <a:solidFill>
+                  <a:srgbClr val="C9D2E8"/>
+                </a:solidFill>
+                <a:latin typeface="Arial"/>
+              </a:rPr>
+              <a:t>Optional video · 2:29 · Week 2 · Ramp It Up 2.0</a:t>
+            </a:r>
+          </a:p>
+        </p:txBody>
+      </p:sp>
+      <p:sp>
+        <p:nvSpPr>
+          <p:cNvPr id="5" name="Watch Badge"/>
+          <p:cNvSpPr/>
+          <p:nvPr/>
+        </p:nvSpPr>
+        <p:spPr>
+          <a:xfrm>
+            <a:off x="10820400" y="256032"/>
+            <a:ext cx="1203960" cy="420624"/>
+          </a:xfrm>
+          <a:prstGeom prst="roundRect">
+            <a:avLst/>
+          </a:prstGeom>
+          <a:solidFill>
+            <a:srgbClr val="C05014"/>
+          </a:solidFill>
+          <a:ln>
+            <a:noFill/>
+          </a:ln>
+        </p:spPr>
+        <p:style>
+          <a:lnRef idx="1">
+            <a:schemeClr val="accent1"/>
+          </a:lnRef>
+          <a:fillRef idx="3">
+            <a:schemeClr val="accent1"/>
+          </a:fillRef>
+          <a:effectRef idx="2">
+            <a:schemeClr val="accent1"/>
+          </a:effectRef>
+          <a:fontRef idx="minor">
+            <a:schemeClr val="lt1"/>
+          </a:fontRef>
+        </p:style>
+        <p:txBody>
+          <a:bodyPr rtlCol="0" anchor="ctr" wrap="none"/>
+          <a:lstStyle/>
+          <a:p>
+            <a:pPr algn="ctr"/>
+            <a:r>
+              <a:rPr sz="1100" b="1">
+                <a:solidFill>
+                  <a:srgbClr val="FFFFFF"/>
+                </a:solidFill>
+                <a:latin typeface="Arial"/>
+              </a:rPr>
+              <a:t>WATCH</a:t>
+            </a:r>
+          </a:p>
+        </p:txBody>
+      </p:sp>
+      <p:pic>
+        <p:nvPicPr>
+          <p:cNvPr id="6" name="Video 1">
+            <a:extLst>
+              <a:ext uri="{DAA4B4D4-6D71-4841-9C94-3DE7FCFB9230}">
+                <p14:media xmlns:p14="http://schemas.microsoft.com/office/powerpoint/2010/main" r:embed="rId3"/>
+              </a:ext>
+            </a:extLst>
+          </p:cNvPr>
+          <p:cNvPicPr>
+            <a:picLocks noChangeAspect="1"/>
+          </p:cNvPicPr>
+          <p:nvPr>
+            <a:videoFile r:link="rId3"/>
+            <p:extLst>
+              <p:ext uri="{DAA4B4D4-6D71-4841-9C94-3DE7FCFB9230}">
+                <p14:media xmlns:p14="http://schemas.microsoft.com/office/powerpoint/2010/main" r:embed="rId3"/>
+              </p:ext>
+            </p:extLst>
+          </p:nvPr>
+        </p:nvPicPr>
+        <p:blipFill>
+          <a:blip r:embed="rId2"/>
+          <a:stretch>
+            <a:fillRect/>
+          </a:stretch>
+        </p:blipFill>
+        <p:spPr>
+          <a:xfrm>
+            <a:off x="1895847" y="1720000"/>
+            <a:ext cx="8400000" cy="4725000"/>
+          </a:xfrm>
+          <a:prstGeom prst="rect">
+            <a:avLst/>
+          </a:prstGeom>
+        </p:spPr>
+      </p:pic>
+      <p:sp>
+        <p:nvSpPr>
+          <p:cNvPr id="7" name="Prompt"/>
+          <p:cNvSpPr txBox="1"/>
+          <p:nvPr/>
+        </p:nvSpPr>
+        <p:spPr>
+          <a:xfrm>
+            <a:off x="457200" y="6500000"/>
+            <a:ext cx="11277295" cy="300000"/>
+          </a:xfrm>
+          <a:prstGeom prst="rect">
+            <a:avLst/>
+          </a:prstGeom>
+          <a:noFill/>
+        </p:spPr>
+        <p:txBody>
+          <a:bodyPr wrap="square" anchor="ctr">
+            <a:spAutoFit/>
+          </a:bodyPr>
+          <a:lstStyle/>
+          <a:p>
+            <a:pPr algn="ctr"/>
+            <a:r>
+              <a:rPr sz="1800" b="1">
+                <a:solidFill>
+                  <a:srgbClr val="1F3A5F"/>
+                </a:solidFill>
+                <a:latin typeface="Arial"/>
+              </a:rPr>
+              <a:t>THINK: Which variable changed, and which stayed the same?</a:t>
+            </a:r>
+          </a:p>
+        </p:txBody>
+      </p:sp>
+      <p:sp>
+        <p:nvSpPr>
+          <p:cNvPr id="8" name="Slide Number"/>
+          <p:cNvSpPr txBox="1"/>
+          <p:nvPr/>
+        </p:nvSpPr>
+        <p:spPr>
+          <a:xfrm>
+            <a:off x="11338560" y="6446520"/>
+            <a:ext cx="731520" cy="365760"/>
+          </a:xfrm>
+          <a:prstGeom prst="rect">
+            <a:avLst/>
+          </a:prstGeom>
+          <a:noFill/>
+        </p:spPr>
+        <p:txBody>
+          <a:bodyPr wrap="square" anchor="t">
+            <a:spAutoFit/>
+          </a:bodyPr>
+          <a:lstStyle/>
+          <a:p>
+            <a:pPr algn="r"/>
+            <a:r>
+              <a:rPr sz="1200" b="0">
+                <a:solidFill>
+                  <a:srgbClr val="555555"/>
+                </a:solidFill>
+                <a:latin typeface="Arial"/>
+              </a:rPr>
+              <a:t>17</a:t>
             </a:r>
           </a:p>
         </p:txBody>

</xml_diff>

<commit_message>
Rebuild Chapter 3 product under Grade 4 standards (v1.3)
Fix spec (blankCount, N2 revealSequence, quiz Q4/Q7), remove all stale 'infer' wording, teach Reader p.15 steeper-ramp fact, add fair-test controls + guided reasoning + average column to Ramp It Up, correct practice/quiz/recovery prompts, fix slide chip labels and N2/N3 slide text. Add blind source derivation and Chapters 4-7 read-only preflight.

Co-authored-by: Cursor <cursoragent@cursor.com>
</commit_message>
<xml_diff>
--- a/production/slides/03-ch3-energy-speed-slides.pptx
+++ b/production/slides/03-ch3-energy-speed-slides.pptx
@@ -7305,7 +7305,7 @@
         <p:spPr>
           <a:xfrm>
             <a:off x="548640" y="1051560"/>
-            <a:ext cx="1234440" cy="420624"/>
+            <a:ext cx="1371600" cy="420624"/>
           </a:xfrm>
           <a:prstGeom prst="roundRect">
             <a:avLst>
@@ -7340,7 +7340,7 @@
           <a:p>
             <a:pPr algn="ctr"/>
             <a:r>
-              <a:rPr sz="1800" b="1">
+              <a:rPr sz="1600" b="1">
                 <a:solidFill>
                   <a:srgbClr val="FFFFFF"/>
                 </a:solidFill>
@@ -7626,7 +7626,7 @@
         <p:spPr>
           <a:xfrm>
             <a:off x="548640" y="1051560"/>
-            <a:ext cx="1234440" cy="420624"/>
+            <a:ext cx="1371600" cy="420624"/>
           </a:xfrm>
           <a:prstGeom prst="roundRect">
             <a:avLst>
@@ -7661,7 +7661,7 @@
           <a:p>
             <a:pPr algn="ctr"/>
             <a:r>
-              <a:rPr sz="1800" b="1">
+              <a:rPr sz="1600" b="1">
                 <a:solidFill>
                   <a:srgbClr val="FFFFFF"/>
                 </a:solidFill>
@@ -7979,7 +7979,7 @@
         <p:spPr>
           <a:xfrm>
             <a:off x="548640" y="1051560"/>
-            <a:ext cx="1234440" cy="420624"/>
+            <a:ext cx="1371600" cy="420624"/>
           </a:xfrm>
           <a:prstGeom prst="roundRect">
             <a:avLst>
@@ -8014,7 +8014,7 @@
           <a:p>
             <a:pPr algn="ctr"/>
             <a:r>
-              <a:rPr sz="1800" b="1">
+              <a:rPr sz="1600" b="1">
                 <a:solidFill>
                   <a:srgbClr val="FFFFFF"/>
                 </a:solidFill>
@@ -8316,7 +8316,7 @@
         <p:spPr>
           <a:xfrm>
             <a:off x="548640" y="1051560"/>
-            <a:ext cx="1234440" cy="420624"/>
+            <a:ext cx="1371600" cy="420624"/>
           </a:xfrm>
           <a:prstGeom prst="roundRect">
             <a:avLst>
@@ -8351,7 +8351,7 @@
           <a:p>
             <a:pPr algn="ctr"/>
             <a:r>
-              <a:rPr sz="1800" b="1">
+              <a:rPr sz="1600" b="1">
                 <a:solidFill>
                   <a:srgbClr val="FFFFFF"/>
                 </a:solidFill>
@@ -8637,7 +8637,7 @@
         <p:spPr>
           <a:xfrm>
             <a:off x="548640" y="1051560"/>
-            <a:ext cx="1234440" cy="420624"/>
+            <a:ext cx="1371600" cy="420624"/>
           </a:xfrm>
           <a:prstGeom prst="roundRect">
             <a:avLst>
@@ -8672,7 +8672,7 @@
           <a:p>
             <a:pPr algn="ctr"/>
             <a:r>
-              <a:rPr sz="1800" b="1">
+              <a:rPr sz="1600" b="1">
                 <a:solidFill>
                   <a:srgbClr val="FFFFFF"/>
                 </a:solidFill>
@@ -8958,7 +8958,7 @@
         <p:spPr>
           <a:xfrm>
             <a:off x="548640" y="1051560"/>
-            <a:ext cx="1234440" cy="420624"/>
+            <a:ext cx="1371600" cy="420624"/>
           </a:xfrm>
           <a:prstGeom prst="roundRect">
             <a:avLst>
@@ -8993,7 +8993,7 @@
           <a:p>
             <a:pPr algn="ctr"/>
             <a:r>
-              <a:rPr sz="1800" b="1">
+              <a:rPr sz="1600" b="1">
                 <a:solidFill>
                   <a:srgbClr val="FFFFFF"/>
                 </a:solidFill>
@@ -9279,7 +9279,7 @@
         <p:spPr>
           <a:xfrm>
             <a:off x="548640" y="1051560"/>
-            <a:ext cx="1234440" cy="420624"/>
+            <a:ext cx="1371600" cy="420624"/>
           </a:xfrm>
           <a:prstGeom prst="roundRect">
             <a:avLst>
@@ -9314,7 +9314,7 @@
           <a:p>
             <a:pPr algn="ctr"/>
             <a:r>
-              <a:rPr sz="1800" b="1">
+              <a:rPr sz="1600" b="1">
                 <a:solidFill>
                   <a:srgbClr val="FFFFFF"/>
                 </a:solidFill>
@@ -9485,7 +9485,23 @@
                 </a:solidFill>
                 <a:latin typeface="Avenir Next"/>
               </a:rPr>
-              <a:t>We ________ the speed relationship from that change.</a:t>
+              <a:t>We measure how far the ________ moves in centimeters.</a:t>
+            </a:r>
+          </a:p>
+          <a:p>
+            <a:pPr algn="l">
+              <a:spcAft>
+                <a:spcPts val="1000"/>
+              </a:spcAft>
+            </a:pPr>
+            <a:r>
+              <a:rPr sz="2800" b="1">
+                <a:solidFill>
+                  <a:srgbClr val="1A1D26"/>
+                </a:solidFill>
+                <a:latin typeface="Avenir Next"/>
+              </a:rPr>
+              <a:t>We do not measure a speed number.</a:t>
             </a:r>
           </a:p>
           <a:p>
@@ -9648,7 +9664,7 @@
         <p:spPr>
           <a:xfrm>
             <a:off x="548640" y="1051560"/>
-            <a:ext cx="1234440" cy="420624"/>
+            <a:ext cx="1371600" cy="420624"/>
           </a:xfrm>
           <a:prstGeom prst="roundRect">
             <a:avLst>
@@ -9683,7 +9699,7 @@
           <a:p>
             <a:pPr algn="ctr"/>
             <a:r>
-              <a:rPr sz="1800" b="1">
+              <a:rPr sz="1600" b="1">
                 <a:solidFill>
                   <a:srgbClr val="FFFFFF"/>
                 </a:solidFill>
@@ -9838,7 +9854,23 @@
                 </a:solidFill>
                 <a:latin typeface="Avenir Next"/>
               </a:rPr>
-              <a:t>We infer the speed relationship from that change.</a:t>
+              <a:t>We measure how far the cup moves in centimeters.</a:t>
+            </a:r>
+          </a:p>
+          <a:p>
+            <a:pPr algn="l">
+              <a:spcAft>
+                <a:spcPts val="1000"/>
+              </a:spcAft>
+            </a:pPr>
+            <a:r>
+              <a:rPr sz="2800" b="1">
+                <a:solidFill>
+                  <a:srgbClr val="1A1D26"/>
+                </a:solidFill>
+                <a:latin typeface="Avenir Next"/>
+              </a:rPr>
+              <a:t>We do not measure a speed number.</a:t>
             </a:r>
           </a:p>
           <a:p>
@@ -10001,7 +10033,7 @@
         <p:spPr>
           <a:xfrm>
             <a:off x="548640" y="1051560"/>
-            <a:ext cx="1234440" cy="420624"/>
+            <a:ext cx="1371600" cy="420624"/>
           </a:xfrm>
           <a:prstGeom prst="roundRect">
             <a:avLst>
@@ -10036,7 +10068,7 @@
           <a:p>
             <a:pPr algn="ctr"/>
             <a:r>
-              <a:rPr sz="1800" b="1">
+              <a:rPr sz="1600" b="1">
                 <a:solidFill>
                   <a:srgbClr val="FFFFFF"/>
                 </a:solidFill>
@@ -10338,7 +10370,7 @@
         <p:spPr>
           <a:xfrm>
             <a:off x="548640" y="1051560"/>
-            <a:ext cx="1234440" cy="420624"/>
+            <a:ext cx="1371600" cy="420624"/>
           </a:xfrm>
           <a:prstGeom prst="roundRect">
             <a:avLst>
@@ -10373,7 +10405,7 @@
           <a:p>
             <a:pPr algn="ctr"/>
             <a:r>
-              <a:rPr sz="1800" b="1">
+              <a:rPr sz="1600" b="1">
                 <a:solidFill>
                   <a:srgbClr val="FFFFFF"/>
                 </a:solidFill>
@@ -10659,7 +10691,7 @@
         <p:spPr>
           <a:xfrm>
             <a:off x="548640" y="1051560"/>
-            <a:ext cx="1234440" cy="420624"/>
+            <a:ext cx="1371600" cy="420624"/>
           </a:xfrm>
           <a:prstGeom prst="roundRect">
             <a:avLst>
@@ -10694,7 +10726,7 @@
           <a:p>
             <a:pPr algn="ctr"/>
             <a:r>
-              <a:rPr sz="1800" b="1">
+              <a:rPr sz="1600" b="1">
                 <a:solidFill>
                   <a:srgbClr val="FFFFFF"/>
                 </a:solidFill>
@@ -10980,7 +11012,7 @@
         <p:spPr>
           <a:xfrm>
             <a:off x="548640" y="1051560"/>
-            <a:ext cx="1234440" cy="420624"/>
+            <a:ext cx="1371600" cy="420624"/>
           </a:xfrm>
           <a:prstGeom prst="roundRect">
             <a:avLst>
@@ -11015,7 +11047,7 @@
           <a:p>
             <a:pPr algn="ctr"/>
             <a:r>
-              <a:rPr sz="1800" b="1">
+              <a:rPr sz="1600" b="1">
                 <a:solidFill>
                   <a:srgbClr val="FFFFFF"/>
                 </a:solidFill>
@@ -11317,7 +11349,7 @@
         <p:spPr>
           <a:xfrm>
             <a:off x="548640" y="1051560"/>
-            <a:ext cx="1234440" cy="420624"/>
+            <a:ext cx="1371600" cy="420624"/>
           </a:xfrm>
           <a:prstGeom prst="roundRect">
             <a:avLst>
@@ -11352,7 +11384,7 @@
           <a:p>
             <a:pPr algn="ctr"/>
             <a:r>
-              <a:rPr sz="1800" b="1">
+              <a:rPr sz="1600" b="1">
                 <a:solidFill>
                   <a:srgbClr val="FFFFFF"/>
                 </a:solidFill>
@@ -11638,7 +11670,7 @@
         <p:spPr>
           <a:xfrm>
             <a:off x="548640" y="1051560"/>
-            <a:ext cx="1234440" cy="420624"/>
+            <a:ext cx="1371600" cy="420624"/>
           </a:xfrm>
           <a:prstGeom prst="roundRect">
             <a:avLst>
@@ -11673,7 +11705,7 @@
           <a:p>
             <a:pPr algn="ctr"/>
             <a:r>
-              <a:rPr sz="1800" b="1">
+              <a:rPr sz="1600" b="1">
                 <a:solidFill>
                   <a:srgbClr val="FFFFFF"/>
                 </a:solidFill>
@@ -11943,7 +11975,7 @@
         <p:spPr>
           <a:xfrm>
             <a:off x="548640" y="1051560"/>
-            <a:ext cx="1234440" cy="420624"/>
+            <a:ext cx="1371600" cy="420624"/>
           </a:xfrm>
           <a:prstGeom prst="roundRect">
             <a:avLst>
@@ -11978,7 +12010,7 @@
           <a:p>
             <a:pPr algn="ctr"/>
             <a:r>
-              <a:rPr sz="1800" b="1">
+              <a:rPr sz="1600" b="1">
                 <a:solidFill>
                   <a:srgbClr val="FFFFFF"/>
                 </a:solidFill>
@@ -12248,7 +12280,7 @@
         <p:spPr>
           <a:xfrm>
             <a:off x="548640" y="1051560"/>
-            <a:ext cx="1234440" cy="420624"/>
+            <a:ext cx="1371600" cy="420624"/>
           </a:xfrm>
           <a:prstGeom prst="roundRect">
             <a:avLst>
@@ -12283,7 +12315,7 @@
           <a:p>
             <a:pPr algn="ctr"/>
             <a:r>
-              <a:rPr sz="1800" b="1">
+              <a:rPr sz="1600" b="1">
                 <a:solidFill>
                   <a:srgbClr val="FFFFFF"/>
                 </a:solidFill>
@@ -12601,7 +12633,7 @@
         <p:spPr>
           <a:xfrm>
             <a:off x="548640" y="1051560"/>
-            <a:ext cx="1234440" cy="420624"/>
+            <a:ext cx="1371600" cy="420624"/>
           </a:xfrm>
           <a:prstGeom prst="roundRect">
             <a:avLst>
@@ -12636,7 +12668,7 @@
           <a:p>
             <a:pPr algn="ctr"/>
             <a:r>
-              <a:rPr sz="1800" b="1">
+              <a:rPr sz="1600" b="1">
                 <a:solidFill>
                   <a:srgbClr val="FFFFFF"/>
                 </a:solidFill>
@@ -12922,7 +12954,7 @@
         <p:spPr>
           <a:xfrm>
             <a:off x="548640" y="1051560"/>
-            <a:ext cx="1234440" cy="420624"/>
+            <a:ext cx="1371600" cy="420624"/>
           </a:xfrm>
           <a:prstGeom prst="roundRect">
             <a:avLst>
@@ -12957,7 +12989,7 @@
           <a:p>
             <a:pPr algn="ctr"/>
             <a:r>
-              <a:rPr sz="1800" b="1">
+              <a:rPr sz="1600" b="1">
                 <a:solidFill>
                   <a:srgbClr val="FFFFFF"/>
                 </a:solidFill>
@@ -13243,7 +13275,7 @@
         <p:spPr>
           <a:xfrm>
             <a:off x="548640" y="1051560"/>
-            <a:ext cx="1234440" cy="420624"/>
+            <a:ext cx="1371600" cy="420624"/>
           </a:xfrm>
           <a:prstGeom prst="roundRect">
             <a:avLst>
@@ -13278,7 +13310,7 @@
           <a:p>
             <a:pPr algn="ctr"/>
             <a:r>
-              <a:rPr sz="1800" b="1">
+              <a:rPr sz="1600" b="1">
                 <a:solidFill>
                   <a:srgbClr val="FFFFFF"/>
                 </a:solidFill>
@@ -13580,7 +13612,7 @@
         <p:spPr>
           <a:xfrm>
             <a:off x="548640" y="1051560"/>
-            <a:ext cx="1234440" cy="420624"/>
+            <a:ext cx="1371600" cy="420624"/>
           </a:xfrm>
           <a:prstGeom prst="roundRect">
             <a:avLst>
@@ -13615,7 +13647,7 @@
           <a:p>
             <a:pPr algn="ctr"/>
             <a:r>
-              <a:rPr sz="1800" b="1">
+              <a:rPr sz="1600" b="1">
                 <a:solidFill>
                   <a:srgbClr val="FFFFFF"/>
                 </a:solidFill>
@@ -13770,7 +13802,7 @@
                 </a:solidFill>
                 <a:latin typeface="Avenir Next"/>
               </a:rPr>
-              <a:t>We inferred the speed relationship from that change.</a:t>
+              <a:t>The cup moved farther. That is a greater change.</a:t>
             </a:r>
           </a:p>
         </p:txBody>
@@ -13901,7 +13933,7 @@
         <p:spPr>
           <a:xfrm>
             <a:off x="548640" y="1051560"/>
-            <a:ext cx="1234440" cy="420624"/>
+            <a:ext cx="1371600" cy="420624"/>
           </a:xfrm>
           <a:prstGeom prst="roundRect">
             <a:avLst>
@@ -13936,7 +13968,7 @@
           <a:p>
             <a:pPr algn="ctr"/>
             <a:r>
-              <a:rPr sz="1800" b="1">
+              <a:rPr sz="1600" b="1">
                 <a:solidFill>
                   <a:srgbClr val="FFFFFF"/>
                 </a:solidFill>
@@ -14222,7 +14254,7 @@
         <p:spPr>
           <a:xfrm>
             <a:off x="548640" y="1051560"/>
-            <a:ext cx="1234440" cy="420624"/>
+            <a:ext cx="1371600" cy="420624"/>
           </a:xfrm>
           <a:prstGeom prst="roundRect">
             <a:avLst>
@@ -14257,7 +14289,7 @@
           <a:p>
             <a:pPr algn="ctr"/>
             <a:r>
-              <a:rPr sz="1800" b="1">
+              <a:rPr sz="1600" b="1">
                 <a:solidFill>
                   <a:srgbClr val="FFFFFF"/>
                 </a:solidFill>
@@ -14543,7 +14575,7 @@
         <p:spPr>
           <a:xfrm>
             <a:off x="548640" y="1051560"/>
-            <a:ext cx="1234440" cy="420624"/>
+            <a:ext cx="1371600" cy="420624"/>
           </a:xfrm>
           <a:prstGeom prst="roundRect">
             <a:avLst>
@@ -14578,7 +14610,7 @@
           <a:p>
             <a:pPr algn="ctr"/>
             <a:r>
-              <a:rPr sz="1800" b="1">
+              <a:rPr sz="1600" b="1">
                 <a:solidFill>
                   <a:srgbClr val="FFFFFF"/>
                 </a:solidFill>
@@ -14718,6 +14750,22 @@
                 <a:latin typeface="Avenir Next"/>
               </a:rPr>
               <a:t>A steeper ramp. One ball.</a:t>
+            </a:r>
+          </a:p>
+          <a:p>
+            <a:pPr algn="l">
+              <a:spcAft>
+                <a:spcPts val="1000"/>
+              </a:spcAft>
+            </a:pPr>
+            <a:r>
+              <a:rPr sz="2800" b="1">
+                <a:solidFill>
+                  <a:srgbClr val="1A1D26"/>
+                </a:solidFill>
+                <a:latin typeface="Avenir Next"/>
+              </a:rPr>
+              <a:t>The Reader says objects pick up more speed on steeper ramps.</a:t>
             </a:r>
           </a:p>
           <a:p>
@@ -14864,7 +14912,7 @@
         <p:spPr>
           <a:xfrm>
             <a:off x="548640" y="1051560"/>
-            <a:ext cx="1234440" cy="420624"/>
+            <a:ext cx="1371600" cy="420624"/>
           </a:xfrm>
           <a:prstGeom prst="roundRect">
             <a:avLst>
@@ -14899,7 +14947,7 @@
           <a:p>
             <a:pPr algn="ctr"/>
             <a:r>
-              <a:rPr sz="1800" b="1">
+              <a:rPr sz="1600" b="1">
                 <a:solidFill>
                   <a:srgbClr val="FFFFFF"/>
                 </a:solidFill>
@@ -15038,7 +15086,23 @@
                 </a:solidFill>
                 <a:latin typeface="Avenir Next"/>
               </a:rPr>
-              <a:t>Write the missing word.</a:t>
+              <a:t>Write the missing words.</a:t>
+            </a:r>
+          </a:p>
+          <a:p>
+            <a:pPr algn="l">
+              <a:spcAft>
+                <a:spcPts val="1000"/>
+              </a:spcAft>
+            </a:pPr>
+            <a:r>
+              <a:rPr sz="2800" b="1">
+                <a:solidFill>
+                  <a:srgbClr val="1A1D26"/>
+                </a:solidFill>
+                <a:latin typeface="Avenir Next"/>
+              </a:rPr>
+              <a:t>Objects pick up more ________ on steeper ramps.</a:t>
             </a:r>
           </a:p>
           <a:p>
@@ -15185,7 +15249,7 @@
         <p:spPr>
           <a:xfrm>
             <a:off x="548640" y="1051560"/>
-            <a:ext cx="1234440" cy="420624"/>
+            <a:ext cx="1371600" cy="420624"/>
           </a:xfrm>
           <a:prstGeom prst="roundRect">
             <a:avLst>
@@ -15220,7 +15284,7 @@
           <a:p>
             <a:pPr algn="ctr"/>
             <a:r>
-              <a:rPr sz="1800" b="1">
+              <a:rPr sz="1600" b="1">
                 <a:solidFill>
                   <a:srgbClr val="FFFFFF"/>
                 </a:solidFill>
@@ -15346,6 +15410,22 @@
             <a:spAutoFit/>
           </a:bodyPr>
           <a:lstStyle/>
+          <a:p>
+            <a:pPr algn="l">
+              <a:spcAft>
+                <a:spcPts val="1000"/>
+              </a:spcAft>
+            </a:pPr>
+            <a:r>
+              <a:rPr sz="2800" b="1">
+                <a:solidFill>
+                  <a:srgbClr val="1A1D26"/>
+                </a:solidFill>
+                <a:latin typeface="Avenir Next"/>
+              </a:rPr>
+              <a:t>Objects pick up more speed on steeper ramps.</a:t>
+            </a:r>
+          </a:p>
           <a:p>
             <a:pPr algn="l">
               <a:spcAft>
@@ -15490,7 +15570,7 @@
         <p:spPr>
           <a:xfrm>
             <a:off x="548640" y="1051560"/>
-            <a:ext cx="1234440" cy="420624"/>
+            <a:ext cx="1371600" cy="420624"/>
           </a:xfrm>
           <a:prstGeom prst="roundRect">
             <a:avLst>
@@ -15525,7 +15605,7 @@
           <a:p>
             <a:pPr algn="ctr"/>
             <a:r>
-              <a:rPr sz="1800" b="1">
+              <a:rPr sz="1600" b="1">
                 <a:solidFill>
                   <a:srgbClr val="FFFFFF"/>
                 </a:solidFill>
@@ -15811,7 +15891,7 @@
         <p:spPr>
           <a:xfrm>
             <a:off x="548640" y="1051560"/>
-            <a:ext cx="1234440" cy="420624"/>
+            <a:ext cx="1371600" cy="420624"/>
           </a:xfrm>
           <a:prstGeom prst="roundRect">
             <a:avLst>
@@ -15846,7 +15926,7 @@
           <a:p>
             <a:pPr algn="ctr"/>
             <a:r>
-              <a:rPr sz="1800" b="1">
+              <a:rPr sz="1600" b="1">
                 <a:solidFill>
                   <a:srgbClr val="FFFFFF"/>
                 </a:solidFill>
@@ -16132,7 +16212,7 @@
         <p:spPr>
           <a:xfrm>
             <a:off x="548640" y="1051560"/>
-            <a:ext cx="1234440" cy="420624"/>
+            <a:ext cx="1371600" cy="420624"/>
           </a:xfrm>
           <a:prstGeom prst="roundRect">
             <a:avLst>
@@ -16167,7 +16247,7 @@
           <a:p>
             <a:pPr algn="ctr"/>
             <a:r>
-              <a:rPr sz="1800" b="1">
+              <a:rPr sz="1600" b="1">
                 <a:solidFill>
                   <a:srgbClr val="FFFFFF"/>
                 </a:solidFill>
@@ -16453,7 +16533,7 @@
         <p:spPr>
           <a:xfrm>
             <a:off x="548640" y="1051560"/>
-            <a:ext cx="1234440" cy="420624"/>
+            <a:ext cx="1371600" cy="420624"/>
           </a:xfrm>
           <a:prstGeom prst="roundRect">
             <a:avLst>
@@ -16488,7 +16568,7 @@
           <a:p>
             <a:pPr algn="ctr"/>
             <a:r>
-              <a:rPr sz="1800" b="1">
+              <a:rPr sz="1600" b="1">
                 <a:solidFill>
                   <a:srgbClr val="FFFFFF"/>
                 </a:solidFill>
@@ -16790,7 +16870,7 @@
         <p:spPr>
           <a:xfrm>
             <a:off x="548640" y="1051560"/>
-            <a:ext cx="1234440" cy="420624"/>
+            <a:ext cx="1371600" cy="420624"/>
           </a:xfrm>
           <a:prstGeom prst="roundRect">
             <a:avLst>
@@ -16825,7 +16905,7 @@
           <a:p>
             <a:pPr algn="ctr"/>
             <a:r>
-              <a:rPr sz="1800" b="1">
+              <a:rPr sz="1600" b="1">
                 <a:solidFill>
                   <a:srgbClr val="FFFFFF"/>
                 </a:solidFill>
@@ -17111,7 +17191,7 @@
         <p:spPr>
           <a:xfrm>
             <a:off x="548640" y="1051560"/>
-            <a:ext cx="1234440" cy="420624"/>
+            <a:ext cx="1371600" cy="420624"/>
           </a:xfrm>
           <a:prstGeom prst="roundRect">
             <a:avLst>
@@ -17146,13 +17226,13 @@
           <a:p>
             <a:pPr algn="ctr"/>
             <a:r>
-              <a:rPr sz="1800" b="1">
+              <a:rPr sz="1600" b="1">
                 <a:solidFill>
                   <a:srgbClr val="FFFFFF"/>
                 </a:solidFill>
                 <a:latin typeface="Avenir Next"/>
               </a:rPr>
-              <a:t>BQ_NOW</a:t>
+              <a:t>BQ NOW</a:t>
             </a:r>
           </a:p>
         </p:txBody>
@@ -17448,7 +17528,7 @@
         <p:spPr>
           <a:xfrm>
             <a:off x="548640" y="1051560"/>
-            <a:ext cx="1234440" cy="420624"/>
+            <a:ext cx="1371600" cy="420624"/>
           </a:xfrm>
           <a:prstGeom prst="roundRect">
             <a:avLst>
@@ -17483,13 +17563,13 @@
           <a:p>
             <a:pPr algn="ctr"/>
             <a:r>
-              <a:rPr sz="1800" b="1">
+              <a:rPr sz="1600" b="1">
                 <a:solidFill>
                   <a:srgbClr val="FFFFFF"/>
                 </a:solidFill>
                 <a:latin typeface="Avenir Next"/>
               </a:rPr>
-              <a:t>BQ_NOW</a:t>
+              <a:t>BQ NOW</a:t>
             </a:r>
           </a:p>
         </p:txBody>
@@ -17769,7 +17849,7 @@
         <p:spPr>
           <a:xfrm>
             <a:off x="548640" y="1051560"/>
-            <a:ext cx="1234440" cy="420624"/>
+            <a:ext cx="1371600" cy="420624"/>
           </a:xfrm>
           <a:prstGeom prst="roundRect">
             <a:avLst>
@@ -17804,7 +17884,7 @@
           <a:p>
             <a:pPr algn="ctr"/>
             <a:r>
-              <a:rPr sz="1800" b="1">
+              <a:rPr sz="1600" b="1">
                 <a:solidFill>
                   <a:srgbClr val="FFFFFF"/>
                 </a:solidFill>
@@ -18106,7 +18186,7 @@
         <p:spPr>
           <a:xfrm>
             <a:off x="548640" y="1051560"/>
-            <a:ext cx="1234440" cy="420624"/>
+            <a:ext cx="1371600" cy="420624"/>
           </a:xfrm>
           <a:prstGeom prst="roundRect">
             <a:avLst>
@@ -18141,13 +18221,13 @@
           <a:p>
             <a:pPr algn="ctr"/>
             <a:r>
-              <a:rPr sz="1800" b="1">
+              <a:rPr sz="1600" b="1">
                 <a:solidFill>
                   <a:srgbClr val="FFFFFF"/>
                 </a:solidFill>
                 <a:latin typeface="Avenir Next"/>
               </a:rPr>
-              <a:t>DROP</a:t>
+              <a:t>DROP IT</a:t>
             </a:r>
           </a:p>
         </p:txBody>
@@ -18443,7 +18523,7 @@
         <p:spPr>
           <a:xfrm>
             <a:off x="548640" y="1051560"/>
-            <a:ext cx="1234440" cy="420624"/>
+            <a:ext cx="1371600" cy="420624"/>
           </a:xfrm>
           <a:prstGeom prst="roundRect">
             <a:avLst>
@@ -18478,7 +18558,7 @@
           <a:p>
             <a:pPr algn="ctr"/>
             <a:r>
-              <a:rPr sz="1800" b="1">
+              <a:rPr sz="1600" b="1">
                 <a:solidFill>
                   <a:srgbClr val="FFFFFF"/>
                 </a:solidFill>
@@ -18780,7 +18860,7 @@
         <p:spPr>
           <a:xfrm>
             <a:off x="548640" y="1051560"/>
-            <a:ext cx="1234440" cy="420624"/>
+            <a:ext cx="1371600" cy="420624"/>
           </a:xfrm>
           <a:prstGeom prst="roundRect">
             <a:avLst>
@@ -18815,7 +18895,7 @@
           <a:p>
             <a:pPr algn="ctr"/>
             <a:r>
-              <a:rPr sz="1800" b="1">
+              <a:rPr sz="1600" b="1">
                 <a:solidFill>
                   <a:srgbClr val="FFFFFF"/>
                 </a:solidFill>
@@ -19117,7 +19197,7 @@
         <p:spPr>
           <a:xfrm>
             <a:off x="548640" y="1051560"/>
-            <a:ext cx="1234440" cy="420624"/>
+            <a:ext cx="1371600" cy="420624"/>
           </a:xfrm>
           <a:prstGeom prst="roundRect">
             <a:avLst>
@@ -19152,7 +19232,7 @@
           <a:p>
             <a:pPr algn="ctr"/>
             <a:r>
-              <a:rPr sz="1800" b="1">
+              <a:rPr sz="1600" b="1">
                 <a:solidFill>
                   <a:srgbClr val="FFFFFF"/>
                 </a:solidFill>
@@ -19438,7 +19518,7 @@
         <p:spPr>
           <a:xfrm>
             <a:off x="548640" y="1051560"/>
-            <a:ext cx="1234440" cy="420624"/>
+            <a:ext cx="1371600" cy="420624"/>
           </a:xfrm>
           <a:prstGeom prst="roundRect">
             <a:avLst>
@@ -19473,7 +19553,7 @@
           <a:p>
             <a:pPr algn="ctr"/>
             <a:r>
-              <a:rPr sz="1800" b="1">
+              <a:rPr sz="1600" b="1">
                 <a:solidFill>
                   <a:srgbClr val="FFFFFF"/>
                 </a:solidFill>
@@ -19743,7 +19823,7 @@
         <p:spPr>
           <a:xfrm>
             <a:off x="548640" y="1051560"/>
-            <a:ext cx="1234440" cy="420624"/>
+            <a:ext cx="1371600" cy="420624"/>
           </a:xfrm>
           <a:prstGeom prst="roundRect">
             <a:avLst>
@@ -19778,7 +19858,7 @@
           <a:p>
             <a:pPr algn="ctr"/>
             <a:r>
-              <a:rPr sz="1800" b="1">
+              <a:rPr sz="1600" b="1">
                 <a:solidFill>
                   <a:srgbClr val="FFFFFF"/>
                 </a:solidFill>
@@ -20080,7 +20160,7 @@
         <p:spPr>
           <a:xfrm>
             <a:off x="548640" y="1051560"/>
-            <a:ext cx="1234440" cy="420624"/>
+            <a:ext cx="1371600" cy="420624"/>
           </a:xfrm>
           <a:prstGeom prst="roundRect">
             <a:avLst>
@@ -20115,7 +20195,7 @@
           <a:p>
             <a:pPr algn="ctr"/>
             <a:r>
-              <a:rPr sz="1800" b="1">
+              <a:rPr sz="1600" b="1">
                 <a:solidFill>
                   <a:srgbClr val="FFFFFF"/>
                 </a:solidFill>

</xml_diff>

<commit_message>
Remediate Chapter 3 classroom artifacts
Co-authored-by: Cursor <cursoragent@cursor.com>
</commit_message>
<xml_diff>
--- a/production/slides/03-ch3-energy-speed-slides.pptx
+++ b/production/slides/03-ch3-energy-speed-slides.pptx
@@ -812,7 +812,7 @@
           </a:p>
           <a:p>
             <a:r>
-              <a:t>SAY Say we will measure the ramp and the cup movement in centimeters. Do not say the Tuesday missing words.</a:t>
+              <a:t>SAY Say we will measure the ramp height and how far the target moves, in centimeters. Do not say the Tuesday missing words.</a:t>
             </a:r>
           </a:p>
         </p:txBody>
@@ -1237,7 +1237,7 @@
           </a:p>
           <a:p>
             <a:r>
-              <a:t>SAY The words are height, infer, and same.</a:t>
+              <a:t>SAY The words are height, cup, height, and same.</a:t>
             </a:r>
           </a:p>
         </p:txBody>
@@ -2257,7 +2257,7 @@
           </a:p>
           <a:p>
             <a:r>
-              <a:t>SAY Ask which height made the bigger change. Speed is inferred from that change.</a:t>
+              <a:t>SAY Ask which setup moved the cup farther. Cup movement is evidence of change, not a speed measurement.</a:t>
             </a:r>
           </a:p>
         </p:txBody>
@@ -2512,7 +2512,7 @@
           </a:p>
           <a:p>
             <a:r>
-              <a:t>SAY Steeper ramp. One ball. The bucket or cup moves farther. Do not say the missing word.</a:t>
+              <a:t>SAY Steeper ramp. One ball. The bucket or cup moves farther. Do not say either missing word.</a:t>
             </a:r>
           </a:p>
         </p:txBody>
@@ -2597,7 +2597,7 @@
           </a:p>
           <a:p>
             <a:r>
-              <a:t>SAY Students write the missing word.</a:t>
+              <a:t>SAY Students write both missing words.</a:t>
             </a:r>
           </a:p>
         </p:txBody>
@@ -2682,7 +2682,7 @@
           </a:p>
           <a:p>
             <a:r>
-              <a:t>SAY The word is greater.</a:t>
+              <a:t>SAY The words are speed and greater.</a:t>
             </a:r>
           </a:p>
         </p:txBody>
@@ -7359,8 +7359,8 @@
         </p:nvSpPr>
         <p:spPr>
           <a:xfrm>
-            <a:off x="1920240" y="1005840"/>
-            <a:ext cx="7498079" cy="512064"/>
+            <a:off x="2057400" y="1005840"/>
+            <a:ext cx="7863840" cy="512064"/>
           </a:xfrm>
           <a:prstGeom prst="rect">
             <a:avLst/>
@@ -7680,8 +7680,8 @@
         </p:nvSpPr>
         <p:spPr>
           <a:xfrm>
-            <a:off x="1920240" y="1005840"/>
-            <a:ext cx="7498079" cy="512064"/>
+            <a:off x="2057400" y="1005840"/>
+            <a:ext cx="7863840" cy="512064"/>
           </a:xfrm>
           <a:prstGeom prst="rect">
             <a:avLst/>
@@ -8033,8 +8033,8 @@
         </p:nvSpPr>
         <p:spPr>
           <a:xfrm>
-            <a:off x="1920240" y="1005840"/>
-            <a:ext cx="7498079" cy="512064"/>
+            <a:off x="2057400" y="1005840"/>
+            <a:ext cx="7863840" cy="512064"/>
           </a:xfrm>
           <a:prstGeom prst="rect">
             <a:avLst/>
@@ -8153,7 +8153,7 @@
                 </a:solidFill>
                 <a:latin typeface="Avenir Next"/>
               </a:rPr>
-              <a:t>Tomorrow we measure the ramp and how far the cup moves.</a:t>
+              <a:t>Tomorrow we measure the ramp height and how far the target moves.</a:t>
             </a:r>
           </a:p>
           <a:p>
@@ -8370,8 +8370,8 @@
         </p:nvSpPr>
         <p:spPr>
           <a:xfrm>
-            <a:off x="1920240" y="1005840"/>
-            <a:ext cx="7498079" cy="512064"/>
+            <a:off x="2057400" y="1005840"/>
+            <a:ext cx="7863840" cy="512064"/>
           </a:xfrm>
           <a:prstGeom prst="rect">
             <a:avLst/>
@@ -8691,8 +8691,8 @@
         </p:nvSpPr>
         <p:spPr>
           <a:xfrm>
-            <a:off x="1920240" y="1005840"/>
-            <a:ext cx="7498079" cy="512064"/>
+            <a:off x="2057400" y="1005840"/>
+            <a:ext cx="7863840" cy="512064"/>
           </a:xfrm>
           <a:prstGeom prst="rect">
             <a:avLst/>
@@ -9012,8 +9012,8 @@
         </p:nvSpPr>
         <p:spPr>
           <a:xfrm>
-            <a:off x="1920240" y="1005840"/>
-            <a:ext cx="7498079" cy="512064"/>
+            <a:off x="2057400" y="1005840"/>
+            <a:ext cx="7863840" cy="512064"/>
           </a:xfrm>
           <a:prstGeom prst="rect">
             <a:avLst/>
@@ -9333,8 +9333,8 @@
         </p:nvSpPr>
         <p:spPr>
           <a:xfrm>
-            <a:off x="1920240" y="1005840"/>
-            <a:ext cx="7498079" cy="512064"/>
+            <a:off x="2057400" y="1005840"/>
+            <a:ext cx="7863840" cy="512064"/>
           </a:xfrm>
           <a:prstGeom prst="rect">
             <a:avLst/>
@@ -9718,8 +9718,8 @@
         </p:nvSpPr>
         <p:spPr>
           <a:xfrm>
-            <a:off x="1920240" y="1005840"/>
-            <a:ext cx="7498079" cy="512064"/>
+            <a:off x="2057400" y="1005840"/>
+            <a:ext cx="7863840" cy="512064"/>
           </a:xfrm>
           <a:prstGeom prst="rect">
             <a:avLst/>
@@ -10087,8 +10087,8 @@
         </p:nvSpPr>
         <p:spPr>
           <a:xfrm>
-            <a:off x="1920240" y="1005840"/>
-            <a:ext cx="7498079" cy="512064"/>
+            <a:off x="2057400" y="1005840"/>
+            <a:ext cx="7863840" cy="512064"/>
           </a:xfrm>
           <a:prstGeom prst="rect">
             <a:avLst/>
@@ -10424,8 +10424,8 @@
         </p:nvSpPr>
         <p:spPr>
           <a:xfrm>
-            <a:off x="1920240" y="1005840"/>
-            <a:ext cx="7498079" cy="512064"/>
+            <a:off x="2057400" y="1005840"/>
+            <a:ext cx="7863840" cy="512064"/>
           </a:xfrm>
           <a:prstGeom prst="rect">
             <a:avLst/>
@@ -10745,8 +10745,8 @@
         </p:nvSpPr>
         <p:spPr>
           <a:xfrm>
-            <a:off x="1920240" y="1005840"/>
-            <a:ext cx="7498079" cy="512064"/>
+            <a:off x="2057400" y="1005840"/>
+            <a:ext cx="7863840" cy="512064"/>
           </a:xfrm>
           <a:prstGeom prst="rect">
             <a:avLst/>
@@ -11066,8 +11066,8 @@
         </p:nvSpPr>
         <p:spPr>
           <a:xfrm>
-            <a:off x="1920240" y="1005840"/>
-            <a:ext cx="7498079" cy="512064"/>
+            <a:off x="2057400" y="1005840"/>
+            <a:ext cx="7863840" cy="512064"/>
           </a:xfrm>
           <a:prstGeom prst="rect">
             <a:avLst/>
@@ -11403,8 +11403,8 @@
         </p:nvSpPr>
         <p:spPr>
           <a:xfrm>
-            <a:off x="1920240" y="1005840"/>
-            <a:ext cx="7498079" cy="512064"/>
+            <a:off x="2057400" y="1005840"/>
+            <a:ext cx="7863840" cy="512064"/>
           </a:xfrm>
           <a:prstGeom prst="rect">
             <a:avLst/>
@@ -11724,8 +11724,8 @@
         </p:nvSpPr>
         <p:spPr>
           <a:xfrm>
-            <a:off x="1920240" y="1005840"/>
-            <a:ext cx="7498079" cy="512064"/>
+            <a:off x="2057400" y="1005840"/>
+            <a:ext cx="7863840" cy="512064"/>
           </a:xfrm>
           <a:prstGeom prst="rect">
             <a:avLst/>
@@ -12029,8 +12029,8 @@
         </p:nvSpPr>
         <p:spPr>
           <a:xfrm>
-            <a:off x="1920240" y="1005840"/>
-            <a:ext cx="7498079" cy="512064"/>
+            <a:off x="2057400" y="1005840"/>
+            <a:ext cx="7863840" cy="512064"/>
           </a:xfrm>
           <a:prstGeom prst="rect">
             <a:avLst/>
@@ -12280,7 +12280,7 @@
         <p:spPr>
           <a:xfrm>
             <a:off x="548640" y="1051560"/>
-            <a:ext cx="1371600" cy="420624"/>
+            <a:ext cx="1417320" cy="420624"/>
           </a:xfrm>
           <a:prstGeom prst="roundRect">
             <a:avLst>
@@ -12334,8 +12334,8 @@
         </p:nvSpPr>
         <p:spPr>
           <a:xfrm>
-            <a:off x="1920240" y="1005840"/>
-            <a:ext cx="7498079" cy="512064"/>
+            <a:off x="2103120" y="1005840"/>
+            <a:ext cx="7818119" cy="512064"/>
           </a:xfrm>
           <a:prstGeom prst="rect">
             <a:avLst/>
@@ -12633,7 +12633,7 @@
         <p:spPr>
           <a:xfrm>
             <a:off x="548640" y="1051560"/>
-            <a:ext cx="1371600" cy="420624"/>
+            <a:ext cx="1417320" cy="420624"/>
           </a:xfrm>
           <a:prstGeom prst="roundRect">
             <a:avLst>
@@ -12687,8 +12687,8 @@
         </p:nvSpPr>
         <p:spPr>
           <a:xfrm>
-            <a:off x="1920240" y="1005840"/>
-            <a:ext cx="7498079" cy="512064"/>
+            <a:off x="2103120" y="1005840"/>
+            <a:ext cx="7818119" cy="512064"/>
           </a:xfrm>
           <a:prstGeom prst="rect">
             <a:avLst/>
@@ -13008,8 +13008,8 @@
         </p:nvSpPr>
         <p:spPr>
           <a:xfrm>
-            <a:off x="1920240" y="1005840"/>
-            <a:ext cx="7498079" cy="512064"/>
+            <a:off x="2057400" y="1005840"/>
+            <a:ext cx="7863840" cy="512064"/>
           </a:xfrm>
           <a:prstGeom prst="rect">
             <a:avLst/>
@@ -13329,8 +13329,8 @@
         </p:nvSpPr>
         <p:spPr>
           <a:xfrm>
-            <a:off x="1920240" y="1005840"/>
-            <a:ext cx="7498079" cy="512064"/>
+            <a:off x="2057400" y="1005840"/>
+            <a:ext cx="7863840" cy="512064"/>
           </a:xfrm>
           <a:prstGeom prst="rect">
             <a:avLst/>
@@ -13666,8 +13666,8 @@
         </p:nvSpPr>
         <p:spPr>
           <a:xfrm>
-            <a:off x="1920240" y="1005840"/>
-            <a:ext cx="7498079" cy="512064"/>
+            <a:off x="2057400" y="1005840"/>
+            <a:ext cx="7863840" cy="512064"/>
           </a:xfrm>
           <a:prstGeom prst="rect">
             <a:avLst/>
@@ -13786,7 +13786,7 @@
                 </a:solidFill>
                 <a:latin typeface="Avenir Next"/>
               </a:rPr>
-              <a:t>Which setup made the bigger change?</a:t>
+              <a:t>Which setup moved the cup farther?</a:t>
             </a:r>
           </a:p>
           <a:p>
@@ -13802,7 +13802,7 @@
                 </a:solidFill>
                 <a:latin typeface="Avenir Next"/>
               </a:rPr>
-              <a:t>The cup moved farther. That is a greater change.</a:t>
+              <a:t>A farther cup move is a bigger change.</a:t>
             </a:r>
           </a:p>
         </p:txBody>
@@ -13987,8 +13987,8 @@
         </p:nvSpPr>
         <p:spPr>
           <a:xfrm>
-            <a:off x="1920240" y="1005840"/>
-            <a:ext cx="7498079" cy="512064"/>
+            <a:off x="2057400" y="1005840"/>
+            <a:ext cx="7863840" cy="512064"/>
           </a:xfrm>
           <a:prstGeom prst="rect">
             <a:avLst/>
@@ -14308,8 +14308,8 @@
         </p:nvSpPr>
         <p:spPr>
           <a:xfrm>
-            <a:off x="1920240" y="1005840"/>
-            <a:ext cx="7498079" cy="512064"/>
+            <a:off x="2057400" y="1005840"/>
+            <a:ext cx="7863840" cy="512064"/>
           </a:xfrm>
           <a:prstGeom prst="rect">
             <a:avLst/>
@@ -14629,8 +14629,8 @@
         </p:nvSpPr>
         <p:spPr>
           <a:xfrm>
-            <a:off x="1920240" y="1005840"/>
-            <a:ext cx="7498079" cy="512064"/>
+            <a:off x="2057400" y="1005840"/>
+            <a:ext cx="7863840" cy="512064"/>
           </a:xfrm>
           <a:prstGeom prst="rect">
             <a:avLst/>
@@ -14765,7 +14765,7 @@
                 </a:solidFill>
                 <a:latin typeface="Avenir Next"/>
               </a:rPr>
-              <a:t>The Reader says objects pick up more speed on steeper ramps.</a:t>
+              <a:t>The Reader tells us what happens when the same ball rolls down a steeper ramp.</a:t>
             </a:r>
           </a:p>
           <a:p>
@@ -14966,8 +14966,8 @@
         </p:nvSpPr>
         <p:spPr>
           <a:xfrm>
-            <a:off x="1920240" y="1005840"/>
-            <a:ext cx="7498079" cy="512064"/>
+            <a:off x="2057400" y="1005840"/>
+            <a:ext cx="7863840" cy="512064"/>
           </a:xfrm>
           <a:prstGeom prst="rect">
             <a:avLst/>
@@ -15303,8 +15303,8 @@
         </p:nvSpPr>
         <p:spPr>
           <a:xfrm>
-            <a:off x="1920240" y="1005840"/>
-            <a:ext cx="7498079" cy="512064"/>
+            <a:off x="2057400" y="1005840"/>
+            <a:ext cx="7863840" cy="512064"/>
           </a:xfrm>
           <a:prstGeom prst="rect">
             <a:avLst/>
@@ -15624,8 +15624,8 @@
         </p:nvSpPr>
         <p:spPr>
           <a:xfrm>
-            <a:off x="1920240" y="1005840"/>
-            <a:ext cx="7498079" cy="512064"/>
+            <a:off x="2057400" y="1005840"/>
+            <a:ext cx="7863840" cy="512064"/>
           </a:xfrm>
           <a:prstGeom prst="rect">
             <a:avLst/>
@@ -15945,8 +15945,8 @@
         </p:nvSpPr>
         <p:spPr>
           <a:xfrm>
-            <a:off x="1920240" y="1005840"/>
-            <a:ext cx="7498079" cy="512064"/>
+            <a:off x="2057400" y="1005840"/>
+            <a:ext cx="7863840" cy="512064"/>
           </a:xfrm>
           <a:prstGeom prst="rect">
             <a:avLst/>
@@ -16266,8 +16266,8 @@
         </p:nvSpPr>
         <p:spPr>
           <a:xfrm>
-            <a:off x="1920240" y="1005840"/>
-            <a:ext cx="7498079" cy="512064"/>
+            <a:off x="2057400" y="1005840"/>
+            <a:ext cx="7863840" cy="512064"/>
           </a:xfrm>
           <a:prstGeom prst="rect">
             <a:avLst/>
@@ -16533,7 +16533,7 @@
         <p:spPr>
           <a:xfrm>
             <a:off x="548640" y="1051560"/>
-            <a:ext cx="1371600" cy="420624"/>
+            <a:ext cx="1417320" cy="420624"/>
           </a:xfrm>
           <a:prstGeom prst="roundRect">
             <a:avLst>
@@ -16587,8 +16587,8 @@
         </p:nvSpPr>
         <p:spPr>
           <a:xfrm>
-            <a:off x="1920240" y="1005840"/>
-            <a:ext cx="7498079" cy="512064"/>
+            <a:off x="2103120" y="1005840"/>
+            <a:ext cx="7818119" cy="512064"/>
           </a:xfrm>
           <a:prstGeom prst="rect">
             <a:avLst/>
@@ -16870,7 +16870,7 @@
         <p:spPr>
           <a:xfrm>
             <a:off x="548640" y="1051560"/>
-            <a:ext cx="1371600" cy="420624"/>
+            <a:ext cx="1417320" cy="420624"/>
           </a:xfrm>
           <a:prstGeom prst="roundRect">
             <a:avLst>
@@ -16924,8 +16924,8 @@
         </p:nvSpPr>
         <p:spPr>
           <a:xfrm>
-            <a:off x="1920240" y="1005840"/>
-            <a:ext cx="7498079" cy="512064"/>
+            <a:off x="2103120" y="1005840"/>
+            <a:ext cx="7818119" cy="512064"/>
           </a:xfrm>
           <a:prstGeom prst="rect">
             <a:avLst/>
@@ -17191,7 +17191,7 @@
         <p:spPr>
           <a:xfrm>
             <a:off x="548640" y="1051560"/>
-            <a:ext cx="1371600" cy="420624"/>
+            <a:ext cx="1600200" cy="420624"/>
           </a:xfrm>
           <a:prstGeom prst="roundRect">
             <a:avLst>
@@ -17245,8 +17245,8 @@
         </p:nvSpPr>
         <p:spPr>
           <a:xfrm>
-            <a:off x="1920240" y="1005840"/>
-            <a:ext cx="7498079" cy="512064"/>
+            <a:off x="2286000" y="1005840"/>
+            <a:ext cx="7635240" cy="512064"/>
           </a:xfrm>
           <a:prstGeom prst="rect">
             <a:avLst/>
@@ -17528,7 +17528,7 @@
         <p:spPr>
           <a:xfrm>
             <a:off x="548640" y="1051560"/>
-            <a:ext cx="1371600" cy="420624"/>
+            <a:ext cx="1600200" cy="420624"/>
           </a:xfrm>
           <a:prstGeom prst="roundRect">
             <a:avLst>
@@ -17582,8 +17582,8 @@
         </p:nvSpPr>
         <p:spPr>
           <a:xfrm>
-            <a:off x="1920240" y="1005840"/>
-            <a:ext cx="7498079" cy="512064"/>
+            <a:off x="2286000" y="1005840"/>
+            <a:ext cx="7635240" cy="512064"/>
           </a:xfrm>
           <a:prstGeom prst="rect">
             <a:avLst/>
@@ -17903,8 +17903,8 @@
         </p:nvSpPr>
         <p:spPr>
           <a:xfrm>
-            <a:off x="1920240" y="1005840"/>
-            <a:ext cx="7498079" cy="512064"/>
+            <a:off x="2057400" y="1005840"/>
+            <a:ext cx="7863840" cy="512064"/>
           </a:xfrm>
           <a:prstGeom prst="rect">
             <a:avLst/>
@@ -18186,7 +18186,7 @@
         <p:spPr>
           <a:xfrm>
             <a:off x="548640" y="1051560"/>
-            <a:ext cx="1371600" cy="420624"/>
+            <a:ext cx="1783080" cy="420624"/>
           </a:xfrm>
           <a:prstGeom prst="roundRect">
             <a:avLst>
@@ -18240,8 +18240,8 @@
         </p:nvSpPr>
         <p:spPr>
           <a:xfrm>
-            <a:off x="1920240" y="1005840"/>
-            <a:ext cx="7498079" cy="512064"/>
+            <a:off x="2468880" y="1005840"/>
+            <a:ext cx="7452359" cy="512064"/>
           </a:xfrm>
           <a:prstGeom prst="rect">
             <a:avLst/>
@@ -18523,7 +18523,7 @@
         <p:spPr>
           <a:xfrm>
             <a:off x="548640" y="1051560"/>
-            <a:ext cx="1371600" cy="420624"/>
+            <a:ext cx="1783080" cy="420624"/>
           </a:xfrm>
           <a:prstGeom prst="roundRect">
             <a:avLst>
@@ -18577,8 +18577,8 @@
         </p:nvSpPr>
         <p:spPr>
           <a:xfrm>
-            <a:off x="1920240" y="1005840"/>
-            <a:ext cx="7498079" cy="512064"/>
+            <a:off x="2468880" y="1005840"/>
+            <a:ext cx="7452359" cy="512064"/>
           </a:xfrm>
           <a:prstGeom prst="rect">
             <a:avLst/>
@@ -18914,8 +18914,8 @@
         </p:nvSpPr>
         <p:spPr>
           <a:xfrm>
-            <a:off x="1920240" y="1005840"/>
-            <a:ext cx="7498079" cy="512064"/>
+            <a:off x="2057400" y="1005840"/>
+            <a:ext cx="7863840" cy="512064"/>
           </a:xfrm>
           <a:prstGeom prst="rect">
             <a:avLst/>
@@ -19251,8 +19251,8 @@
         </p:nvSpPr>
         <p:spPr>
           <a:xfrm>
-            <a:off x="1920240" y="1005840"/>
-            <a:ext cx="7498079" cy="512064"/>
+            <a:off x="2057400" y="1005840"/>
+            <a:ext cx="7863840" cy="512064"/>
           </a:xfrm>
           <a:prstGeom prst="rect">
             <a:avLst/>
@@ -19572,8 +19572,8 @@
         </p:nvSpPr>
         <p:spPr>
           <a:xfrm>
-            <a:off x="1920240" y="1005840"/>
-            <a:ext cx="7498079" cy="512064"/>
+            <a:off x="2057400" y="1005840"/>
+            <a:ext cx="7863840" cy="512064"/>
           </a:xfrm>
           <a:prstGeom prst="rect">
             <a:avLst/>
@@ -19877,8 +19877,8 @@
         </p:nvSpPr>
         <p:spPr>
           <a:xfrm>
-            <a:off x="1920240" y="1005840"/>
-            <a:ext cx="7498079" cy="512064"/>
+            <a:off x="2057400" y="1005840"/>
+            <a:ext cx="7863840" cy="512064"/>
           </a:xfrm>
           <a:prstGeom prst="rect">
             <a:avLst/>
@@ -20214,8 +20214,8 @@
         </p:nvSpPr>
         <p:spPr>
           <a:xfrm>
-            <a:off x="1920240" y="1005840"/>
-            <a:ext cx="7498079" cy="512064"/>
+            <a:off x="2057400" y="1005840"/>
+            <a:ext cx="7863840" cy="512064"/>
           </a:xfrm>
           <a:prstGeom prst="rect">
             <a:avLst/>

</xml_diff>